<commit_message>
Fix number inconsistencies; add engagement commitments to talent page
- Standardise to 47+ brands across all pages (meta descriptions and hero stats)
- Fix index.html team card: 23+ → 50+ Senior Practitioners (23 was years, not headcount)
- talent-advisory.html: hero stat 45+ → 47+
- talent-advisory.html: add "What a Retained Engagement Looks Like" section
  (dedicated lead, weekly updates, structured technical assessment, post-placement assurance)
- Pitch deck: rename "Replacement Guarantee" → "Post-Placement Assurance" throughout
- Pitch deck: remove "6-month" timeline language from guarantee text
- "Contract-to-hire" was not in the deck (verbal promise only; not added to site)

Co-Authored-By: Claude Sonnet 4.6 <noreply@anthropic.com>
Claude-Session: https://claude.ai/code/session_018ndVRBJtdLEYzeqPKJApWq
</commit_message>
<xml_diff>
--- a/AppStudioX_TechTalent_Partnership_Deck.pptx
+++ b/AppStudioX_TechTalent_Partnership_Deck.pptx
@@ -4929,7 +4929,7 @@
                 </a:solidFill>
                 <a:latin typeface="Calibri"/>
               </a:rPr>
-              <a:t>✓  Clear 6-month replacement guarantee on every placement</a:t>
+              <a:t>✓  Clear post-placement assurance — we re-engage at no additional fee</a:t>
             </a:r>
           </a:p>
         </p:txBody>
@@ -15147,7 +15147,7 @@
                 </a:solidFill>
                 <a:latin typeface="Calibri"/>
               </a:rPr>
-              <a:t>All engagements include a replacement guarantee. If a placed candidate leaves within 6 months, we fill the role again at no additional fee.</a:t>
+              <a:t>All engagements include a post-placement assurance. If a placed candidate exits early, we re-engage the search at no additional retainer fee.</a:t>
             </a:r>
           </a:p>
         </p:txBody>
@@ -16923,7 +16923,7 @@
                 </a:solidFill>
                 <a:latin typeface="Calibri"/>
               </a:rPr>
-              <a:t>Replacement Guarantee</a:t>
+              <a:t>Post-Placement Assurance</a:t>
             </a:r>
           </a:p>
         </p:txBody>
@@ -16958,7 +16958,7 @@
                 </a:solidFill>
                 <a:latin typeface="Calibri"/>
               </a:rPr>
-              <a:t>6-month replacement guarantee at no additional fee. We stand behind every placement we make.</a:t>
+              <a:t>If a placed candidate exits early, we re-engage the search at no additional retainer. We stand behind every placement we make.</a:t>
             </a:r>
           </a:p>
         </p:txBody>

</xml_diff>